<commit_message>
Pass 4: standalone case-study report, main report expanded 10->18 pages
- reporting/case_study_report.docx (7 pages): real peak-to-trough search,
  detection lag, recovery time, regime-overlay charts for all 4 episodes.
  Found the model has a 174-trading-day blind spot at the start of 2008
  due to the 252-day feature warmup -- a real, previously undocumented gap.
- Main report: added full Baum-Welch derivation, Dirichlet/NIG conjugacy
  proofs, MC-Dropout theory, conformal coverage proof sketch, BOCPD
  derivation, a worked numerical example on the real 2020-03-23 Covid
  trough date, a real IC artefact example, per-regime feature statistics,
  an HMM-vs-rules-based confusion matrix, and a reproducibility appendix.
- Deck and README updated to reference both new deliverables.
</commit_message>
<xml_diff>
--- a/reporting/deck/regime_engine_deck.pptx
+++ b/reporting/deck/regime_engine_deck.pptx
@@ -8912,6 +8912,27 @@
                 <a:ea typeface="Calibri" pitchFamily="34" charset="-122"/>
                 <a:cs typeface="Calibri" pitchFamily="34" charset="-120"/>
               </a:rPr>
+              <a:t>Added this pass: standalone case-study deep-dive report + git repo committed and submission-ready</a:t>
+            </a:r>
+            <a:endParaRPr lang="en-US" sz="1400" dirty="0"/>
+          </a:p>
+          <a:p>
+            <a:pPr marL="342900" indent="-342900">
+              <a:spcAft>
+                <a:spcPts val="900"/>
+              </a:spcAft>
+              <a:buSzPct val="100000"/>
+              <a:buChar char="•"/>
+            </a:pPr>
+            <a:r>
+              <a:rPr lang="en-US" sz="1400" dirty="0">
+                <a:solidFill>
+                  <a:srgbClr val="CADCFC"/>
+                </a:solidFill>
+                <a:latin typeface="Calibri" pitchFamily="34" charset="0"/>
+                <a:ea typeface="Calibri" pitchFamily="34" charset="-122"/>
+                <a:cs typeface="Calibri" pitchFamily="34" charset="-120"/>
+              </a:rPr>
               <a:t>Not built: demo video (full script provided instead), GitHub repo transfer — outside this tool's capability / requires account owner</a:t>
             </a:r>
             <a:endParaRPr lang="en-US" sz="1400" dirty="0"/>

</xml_diff>